<commit_message>
refactor: Clean up workspace, remove root & docs redundancies, organize audio and add Carrier Board v2
</commit_message>
<xml_diff>
--- a/docs/Daneben_1Min_Sales_Pitch.pptx
+++ b/docs/Daneben_1Min_Sales_Pitch.pptx
@@ -13,6 +13,7 @@
     <p:sldId id="261" r:id="rId13"/>
     <p:sldId id="262" r:id="rId14"/>
     <p:sldId id="263" r:id="rId15"/>
+    <p:sldId id="264" r:id="rId16"/>
   </p:sldIdLst>
   <p:sldSz cx="12191695" cy="6858000" type="screen4x3"/>
   <p:notesSz cx="6858000" cy="9144000"/>
@@ -514,7 +515,7 @@
           </a:p>
           <a:p>
             <a:r>
-              <a:t>"Every city struggles with trash bags piled up next to public bins. We are the team from Hochschule Niederrhein, and we developed 'Daneben!'—the first solar-powered Edge-AI retrofit that detects side-dumping in real time, checks if space remains inside, and actively intervenes before the person walks away."</a:t>
+              <a:t>"Every city struggles with trash bags piled up next to public bins. We are the team from Hochschule Niederrhein—Chukwuekwugo Egbuonu, Hilary Mubwandarikwa, and Ala Temimi—and we developed 'Daneben!'—the first solar-powered Edge-AI retrofit that detects side-dumping in real time, checks if space remains inside, and actively intervenes before the person walks away."</a:t>
             </a:r>
           </a:p>
         </p:txBody>
@@ -1040,6 +1041,81 @@
           <a:p>
             <a:r>
               <a:t>"At just €27 in production costs and €4 per month in software subscription, one city generates €240,000 in recurring revenue. Our prototype, firmware, and IP67 CAD tooling are ready. Join us in launching our 50-bin municipal pilot—because trash belongs in the bin, never 'Daneben!' Thank you."</a:t>
+            </a:r>
+          </a:p>
+        </p:txBody>
+      </p:sp>
+      <p:sp>
+        <p:nvSpPr>
+          <p:cNvPr id="4" name="Slide Number Placeholder 3"/>
+          <p:cNvSpPr>
+            <a:spLocks noGrp="1"/>
+          </p:cNvSpPr>
+          <p:nvPr>
+            <p:ph type="sldNum" idx="5" sz="quarter"/>
+          </p:nvPr>
+        </p:nvSpPr>
+        <p:spPr/>
+      </p:sp>
+    </p:spTree>
+  </p:cSld>
+  <p:clrMapOvr>
+    <a:masterClrMapping/>
+  </p:clrMapOvr>
+</p:notes>
+</file>
+
+<file path=ppt/notesSlides/notesSlide9.xml><?xml version="1.0" encoding="utf-8"?>
+<p:notes xmlns:a="http://schemas.openxmlformats.org/drawingml/2006/main" xmlns:p="http://schemas.openxmlformats.org/presentationml/2006/main" xmlns:r="http://schemas.openxmlformats.org/officeDocument/2006/relationships">
+  <p:cSld>
+    <p:spTree>
+      <p:nvGrpSpPr>
+        <p:cNvPr id="1" name=""/>
+        <p:cNvGrpSpPr/>
+        <p:nvPr/>
+      </p:nvGrpSpPr>
+      <p:grpSpPr>
+        <a:xfrm>
+          <a:off x="0" y="0"/>
+          <a:ext cx="0" cy="0"/>
+          <a:chOff x="0" y="0"/>
+          <a:chExt cx="0" cy="0"/>
+        </a:xfrm>
+      </p:grpSpPr>
+      <p:sp>
+        <p:nvSpPr>
+          <p:cNvPr id="2" name="Slide Image Placeholder 1"/>
+          <p:cNvSpPr>
+            <a:spLocks noGrp="1"/>
+          </p:cNvSpPr>
+          <p:nvPr>
+            <p:ph type="sldImg" idx="2"/>
+          </p:nvPr>
+        </p:nvSpPr>
+        <p:spPr/>
+      </p:sp>
+      <p:sp>
+        <p:nvSpPr>
+          <p:cNvPr id="3" name="Notes Placeholder 2"/>
+          <p:cNvSpPr>
+            <a:spLocks noGrp="1"/>
+          </p:cNvSpPr>
+          <p:nvPr>
+            <p:ph type="body" idx="3" sz="quarter"/>
+          </p:nvPr>
+        </p:nvSpPr>
+        <p:spPr/>
+        <p:txBody>
+          <a:bodyPr/>
+          <a:lstStyle/>
+          <a:p>
+            <a:r>
+              <a:t>[Wrap-up &amp; Q&amp;A]</a:t>
+            </a:r>
+          </a:p>
+          <a:p>
+            <a:r>
+              <a:t>"Thank you very much for your time and for listening! Our vision with Daneben! is simple: let's keep the city clean together. By combining on-spot acoustic nudging, privacy-first edge AI, and smart municipal fleet dispatch, we stop side-waste at the source. We are now excited to take your questions and discuss our upcoming pilot deployment."</a:t>
             </a:r>
           </a:p>
         </p:txBody>
@@ -4150,7 +4226,7 @@
         <p:spPr>
           <a:xfrm>
             <a:off x="731520" y="4114800"/>
-            <a:ext cx="6035040" cy="1737360"/>
+            <a:ext cx="6263640" cy="1737360"/>
           </a:xfrm>
           <a:prstGeom prst="roundRect">
             <a:avLst/>
@@ -4199,7 +4275,7 @@
               <a:spcBef>
                 <a:spcPts val="400"/>
               </a:spcBef>
-              <a:defRPr sz="1300" b="1">
+              <a:defRPr sz="1200" b="1">
                 <a:solidFill>
                   <a:srgbClr val="0F172A"/>
                 </a:solidFill>
@@ -4207,7 +4283,7 @@
               </a:defRPr>
             </a:pPr>
             <a:r>
-              <a:t>Lead: [Your Name]   |   Team: [Member 2], [Member 3]</a:t>
+              <a:t>Lead: Chukwuekwugo Egbuonu   |   Team: Hilary Mubwandarikwa, Ala Temimi</a:t>
             </a:r>
           </a:p>
           <a:p>
@@ -4296,7 +4372,7 @@
               </a:defRPr>
             </a:pPr>
             <a:r>
-              <a:t>DANEBEN!  |  Production Presentation &amp; Sales Pitch (Standard Edition)  |  Slide 1 of 8</a:t>
+              <a:t>DANEBEN!  |  Production Presentation &amp; Sales Pitch (Standard Edition)  |  Slide 1 of 9</a:t>
             </a:r>
           </a:p>
         </p:txBody>
@@ -4655,7 +4731,7 @@
               </a:defRPr>
             </a:pPr>
             <a:r>
-              <a:t>DANEBEN!  |  Production Presentation &amp; Sales Pitch (Standard Edition)  |  Slide 2 of 8</a:t>
+              <a:t>DANEBEN!  |  Production Presentation &amp; Sales Pitch (Standard Edition)  |  Slide 2 of 9</a:t>
             </a:r>
           </a:p>
         </p:txBody>
@@ -5014,7 +5090,7 @@
               </a:defRPr>
             </a:pPr>
             <a:r>
-              <a:t>DANEBEN!  |  Production Presentation &amp; Sales Pitch (Standard Edition)  |  Slide 3 of 8</a:t>
+              <a:t>DANEBEN!  |  Production Presentation &amp; Sales Pitch (Standard Edition)  |  Slide 3 of 9</a:t>
             </a:r>
           </a:p>
         </p:txBody>
@@ -5389,7 +5465,7 @@
               </a:defRPr>
             </a:pPr>
             <a:r>
-              <a:t>DANEBEN!  |  Production Presentation &amp; Sales Pitch (Standard Edition)  |  Slide 4 of 8</a:t>
+              <a:t>DANEBEN!  |  Production Presentation &amp; Sales Pitch (Standard Edition)  |  Slide 4 of 9</a:t>
             </a:r>
           </a:p>
         </p:txBody>
@@ -5983,7 +6059,7 @@
               </a:defRPr>
             </a:pPr>
             <a:r>
-              <a:t>DANEBEN!  |  Production Presentation &amp; Sales Pitch (Standard Edition)  |  Slide 5 of 8</a:t>
+              <a:t>DANEBEN!  |  Production Presentation &amp; Sales Pitch (Standard Edition)  |  Slide 5 of 9</a:t>
             </a:r>
           </a:p>
         </p:txBody>
@@ -7253,7 +7329,7 @@
               </a:defRPr>
             </a:pPr>
             <a:r>
-              <a:t>DANEBEN!  |  Production Presentation &amp; Sales Pitch (Standard Edition)  |  Slide 6 of 8</a:t>
+              <a:t>DANEBEN!  |  Production Presentation &amp; Sales Pitch (Standard Edition)  |  Slide 6 of 9</a:t>
             </a:r>
           </a:p>
         </p:txBody>
@@ -7853,7 +7929,7 @@
               </a:defRPr>
             </a:pPr>
             <a:r>
-              <a:t>DANEBEN!  |  Production Presentation &amp; Sales Pitch (Standard Edition)  |  Slide 7 of 8</a:t>
+              <a:t>DANEBEN!  |  Production Presentation &amp; Sales Pitch (Standard Edition)  |  Slide 7 of 9</a:t>
             </a:r>
           </a:p>
         </p:txBody>
@@ -8302,7 +8378,559 @@
               </a:defRPr>
             </a:pPr>
             <a:r>
-              <a:t>DANEBEN!  |  Production Presentation &amp; Sales Pitch (Standard Edition)  |  Slide 8 of 8</a:t>
+              <a:t>DANEBEN!  |  Production Presentation &amp; Sales Pitch (Standard Edition)  |  Slide 8 of 9</a:t>
+            </a:r>
+          </a:p>
+        </p:txBody>
+      </p:sp>
+    </p:spTree>
+  </p:cSld>
+  <p:clrMapOvr>
+    <a:masterClrMapping/>
+  </p:clrMapOvr>
+</p:sld>
+</file>
+
+<file path=ppt/slides/slide9.xml><?xml version="1.0" encoding="utf-8"?>
+<p:sld xmlns:a="http://schemas.openxmlformats.org/drawingml/2006/main" xmlns:p="http://schemas.openxmlformats.org/presentationml/2006/main" xmlns:r="http://schemas.openxmlformats.org/officeDocument/2006/relationships">
+  <p:cSld>
+    <p:bg>
+      <p:bgPr>
+        <a:solidFill>
+          <a:srgbClr val="FFFFFF"/>
+        </a:solidFill>
+        <a:effectLst/>
+      </p:bgPr>
+    </p:bg>
+    <p:spTree>
+      <p:nvGrpSpPr>
+        <p:cNvPr id="1" name=""/>
+        <p:cNvGrpSpPr/>
+        <p:nvPr/>
+      </p:nvGrpSpPr>
+      <p:grpSpPr/>
+      <p:sp>
+        <p:nvSpPr>
+          <p:cNvPr id="2" name="Rounded Rectangle 1"/>
+          <p:cNvSpPr/>
+          <p:nvPr/>
+        </p:nvSpPr>
+        <p:spPr>
+          <a:xfrm>
+            <a:off x="731520" y="438912"/>
+            <a:ext cx="3474720" cy="347472"/>
+          </a:xfrm>
+          <a:prstGeom prst="roundRect">
+            <a:avLst/>
+          </a:prstGeom>
+          <a:solidFill>
+            <a:srgbClr val="F8FAFC"/>
+          </a:solidFill>
+          <a:ln w="19050">
+            <a:solidFill>
+              <a:srgbClr val="10B981"/>
+            </a:solidFill>
+          </a:ln>
+        </p:spPr>
+        <p:style>
+          <a:lnRef idx="1">
+            <a:schemeClr val="accent1"/>
+          </a:lnRef>
+          <a:fillRef idx="3">
+            <a:schemeClr val="accent1"/>
+          </a:fillRef>
+          <a:effectRef idx="2">
+            <a:schemeClr val="accent1"/>
+          </a:effectRef>
+          <a:fontRef idx="minor">
+            <a:schemeClr val="lt1"/>
+          </a:fontRef>
+        </p:style>
+        <p:txBody>
+          <a:bodyPr rtlCol="0" anchor="ctr" wrap="none"/>
+          <a:lstStyle/>
+          <a:p>
+            <a:pPr algn="ctr">
+              <a:defRPr sz="1100" b="1">
+                <a:solidFill>
+                  <a:srgbClr val="10B981"/>
+                </a:solidFill>
+                <a:latin typeface="Segoe UI"/>
+              </a:defRPr>
+            </a:pPr>
+            <a:r>
+              <a:t>WRAP-UP &amp; QUESTIONS  |  Q&amp;A</a:t>
+            </a:r>
+          </a:p>
+        </p:txBody>
+      </p:sp>
+      <p:sp>
+        <p:nvSpPr>
+          <p:cNvPr id="3" name="TextBox 2"/>
+          <p:cNvSpPr txBox="1"/>
+          <p:nvPr/>
+        </p:nvSpPr>
+        <p:spPr>
+          <a:xfrm>
+            <a:off x="731520" y="868680"/>
+            <a:ext cx="10698480" cy="658368"/>
+          </a:xfrm>
+          <a:prstGeom prst="rect">
+            <a:avLst/>
+          </a:prstGeom>
+          <a:noFill/>
+        </p:spPr>
+        <p:txBody>
+          <a:bodyPr wrap="square">
+            <a:spAutoFit/>
+          </a:bodyPr>
+          <a:lstStyle/>
+          <a:p>
+            <a:pPr>
+              <a:defRPr sz="2400" b="1">
+                <a:solidFill>
+                  <a:srgbClr val="0F172A"/>
+                </a:solidFill>
+                <a:latin typeface="Segoe UI"/>
+              </a:defRPr>
+            </a:pPr>
+            <a:r>
+              <a:t>Thank You for Listening! Let's Keep the City Clean.</a:t>
+            </a:r>
+          </a:p>
+        </p:txBody>
+      </p:sp>
+      <p:sp>
+        <p:nvSpPr>
+          <p:cNvPr id="4" name="Rounded Rectangle 3"/>
+          <p:cNvSpPr/>
+          <p:nvPr/>
+        </p:nvSpPr>
+        <p:spPr>
+          <a:xfrm>
+            <a:off x="731520" y="1691640"/>
+            <a:ext cx="5120640" cy="4480560"/>
+          </a:xfrm>
+          <a:prstGeom prst="roundRect">
+            <a:avLst/>
+          </a:prstGeom>
+          <a:solidFill>
+            <a:srgbClr val="F8FAFC"/>
+          </a:solidFill>
+          <a:ln w="19050">
+            <a:solidFill>
+              <a:srgbClr val="10B981"/>
+            </a:solidFill>
+          </a:ln>
+        </p:spPr>
+        <p:style>
+          <a:lnRef idx="1">
+            <a:schemeClr val="accent1"/>
+          </a:lnRef>
+          <a:fillRef idx="3">
+            <a:schemeClr val="accent1"/>
+          </a:fillRef>
+          <a:effectRef idx="2">
+            <a:schemeClr val="accent1"/>
+          </a:effectRef>
+          <a:fontRef idx="minor">
+            <a:schemeClr val="lt1"/>
+          </a:fontRef>
+        </p:style>
+        <p:txBody>
+          <a:bodyPr rtlCol="0" anchor="ctr" wrap="square"/>
+          <a:lstStyle/>
+          <a:p>
+            <a:pPr algn="ctr">
+              <a:defRPr sz="1100" b="1">
+                <a:solidFill>
+                  <a:srgbClr val="10B981"/>
+                </a:solidFill>
+                <a:latin typeface="Segoe UI"/>
+              </a:defRPr>
+            </a:pPr>
+            <a:r>
+              <a:t>🌱 OUR SHARED MISSION</a:t>
+            </a:r>
+          </a:p>
+          <a:p>
+            <a:pPr>
+              <a:spcBef>
+                <a:spcPts val="400"/>
+              </a:spcBef>
+              <a:defRPr sz="2600" b="1">
+                <a:solidFill>
+                  <a:srgbClr val="0F172A"/>
+                </a:solidFill>
+                <a:latin typeface="Segoe UI"/>
+              </a:defRPr>
+            </a:pPr>
+            <a:r>
+              <a:t>“Let's keep the city clean!”</a:t>
+            </a:r>
+          </a:p>
+          <a:p>
+            <a:pPr>
+              <a:spcBef>
+                <a:spcPts val="400"/>
+              </a:spcBef>
+              <a:defRPr sz="1350" b="1">
+                <a:solidFill>
+                  <a:srgbClr val="10B981"/>
+                </a:solidFill>
+                <a:latin typeface="Segoe UI"/>
+              </a:defRPr>
+            </a:pPr>
+            <a:r>
+              <a:t>Trash belongs in the bin — never “Daneben!”</a:t>
+            </a:r>
+          </a:p>
+          <a:p>
+            <a:pPr>
+              <a:spcBef>
+                <a:spcPts val="600"/>
+              </a:spcBef>
+            </a:pPr>
+            <a:r>
+              <a:rPr sz="1150" b="1">
+                <a:solidFill>
+                  <a:srgbClr val="0F172A"/>
+                </a:solidFill>
+                <a:latin typeface="Segoe UI"/>
+              </a:rPr>
+              <a:t>• Active Citizen Nudging:</a:t>
+            </a:r>
+            <a:r>
+              <a:rPr sz="1150">
+                <a:solidFill>
+                  <a:srgbClr val="64748B"/>
+                </a:solidFill>
+                <a:latin typeface="Segoe UI"/>
+              </a:rPr>
+              <a:t> Immediate voice prompts correct littering behavior before bags accumulate.</a:t>
+            </a:r>
+          </a:p>
+          <a:p>
+            <a:pPr>
+              <a:spcBef>
+                <a:spcPts val="600"/>
+              </a:spcBef>
+            </a:pPr>
+            <a:r>
+              <a:rPr sz="1150" b="1">
+                <a:solidFill>
+                  <a:srgbClr val="0F172A"/>
+                </a:solidFill>
+                <a:latin typeface="Segoe UI"/>
+              </a:rPr>
+              <a:t>• 100% Privacy &amp; GDPR:</a:t>
+            </a:r>
+            <a:r>
+              <a:rPr sz="1150">
+                <a:solidFill>
+                  <a:srgbClr val="64748B"/>
+                </a:solidFill>
+                <a:latin typeface="Segoe UI"/>
+              </a:rPr>
+              <a:t> On-chip neural inference in 220ms; zero video footage saved or uploaded.</a:t>
+            </a:r>
+          </a:p>
+          <a:p>
+            <a:pPr>
+              <a:spcBef>
+                <a:spcPts val="600"/>
+              </a:spcBef>
+            </a:pPr>
+            <a:r>
+              <a:rPr sz="1150" b="1">
+                <a:solidFill>
+                  <a:srgbClr val="0F172A"/>
+                </a:solidFill>
+                <a:latin typeface="Segoe UI"/>
+              </a:rPr>
+              <a:t>• Fleet Efficiency:</a:t>
+            </a:r>
+            <a:r>
+              <a:rPr sz="1150">
+                <a:solidFill>
+                  <a:srgbClr val="64748B"/>
+                </a:solidFill>
+                <a:latin typeface="Segoe UI"/>
+              </a:rPr>
+              <a:t> Dynamic dispatch eliminates up to 30% of unnecessary empty-bin truck routes.</a:t>
+            </a:r>
+          </a:p>
+          <a:p>
+            <a:pPr>
+              <a:spcBef>
+                <a:spcPts val="600"/>
+              </a:spcBef>
+            </a:pPr>
+            <a:r>
+              <a:rPr sz="1150" b="1">
+                <a:solidFill>
+                  <a:srgbClr val="0F172A"/>
+                </a:solidFill>
+                <a:latin typeface="Segoe UI"/>
+              </a:rPr>
+              <a:t>• Scalable Solar Retrofit:</a:t>
+            </a:r>
+            <a:r>
+              <a:rPr sz="1150">
+                <a:solidFill>
+                  <a:srgbClr val="64748B"/>
+                </a:solidFill>
+                <a:latin typeface="Segoe UI"/>
+              </a:rPr>
+              <a:t> IP67 weatherproof enclosure mounts to existing municipal bins in minutes.</a:t>
+            </a:r>
+          </a:p>
+          <a:p>
+            <a:pPr>
+              <a:spcBef>
+                <a:spcPts val="1400"/>
+              </a:spcBef>
+              <a:defRPr sz="1050" b="1">
+                <a:solidFill>
+                  <a:srgbClr val="0F172A"/>
+                </a:solidFill>
+                <a:latin typeface="Segoe UI"/>
+              </a:defRPr>
+            </a:pPr>
+            <a:r>
+              <a:t>Hochschule Niederrhein (HSNR) · Faculty of Electrical Engineering &amp; CS</a:t>
+            </a:r>
+          </a:p>
+          <a:p>
+            <a:pPr>
+              <a:spcBef>
+                <a:spcPts val="200"/>
+              </a:spcBef>
+              <a:defRPr sz="950">
+                <a:solidFill>
+                  <a:srgbClr val="64748B"/>
+                </a:solidFill>
+                <a:latin typeface="Segoe UI"/>
+              </a:defRPr>
+            </a:pPr>
+            <a:r>
+              <a:t>Team: Chukwuekwugo Egbuonu (Lead), Hilary Mubwandarikwa, Ala Temimi</a:t>
+            </a:r>
+            <a:br/>
+            <a:r>
+              <a:t>Project: Daneben! · Course: Microcontrollers (5th Sem.) · Ready for Municipal Pilots in NRW</a:t>
+            </a:r>
+          </a:p>
+        </p:txBody>
+      </p:sp>
+      <p:sp>
+        <p:nvSpPr>
+          <p:cNvPr id="5" name="Rounded Rectangle 4"/>
+          <p:cNvSpPr/>
+          <p:nvPr/>
+        </p:nvSpPr>
+        <p:spPr>
+          <a:xfrm>
+            <a:off x="6080760" y="1691640"/>
+            <a:ext cx="5349240" cy="4480560"/>
+          </a:xfrm>
+          <a:prstGeom prst="roundRect">
+            <a:avLst/>
+          </a:prstGeom>
+          <a:solidFill>
+            <a:srgbClr val="F8FAFC"/>
+          </a:solidFill>
+          <a:ln w="19050">
+            <a:solidFill>
+              <a:srgbClr val="E2E8F0"/>
+            </a:solidFill>
+          </a:ln>
+        </p:spPr>
+        <p:style>
+          <a:lnRef idx="1">
+            <a:schemeClr val="accent1"/>
+          </a:lnRef>
+          <a:fillRef idx="3">
+            <a:schemeClr val="accent1"/>
+          </a:fillRef>
+          <a:effectRef idx="2">
+            <a:schemeClr val="accent1"/>
+          </a:effectRef>
+          <a:fontRef idx="minor">
+            <a:schemeClr val="lt1"/>
+          </a:fontRef>
+        </p:style>
+        <p:txBody>
+          <a:bodyPr rtlCol="0" anchor="ctr"/>
+          <a:lstStyle/>
+          <a:p>
+            <a:pPr algn="ctr"/>
+          </a:p>
+        </p:txBody>
+      </p:sp>
+      <p:sp>
+        <p:nvSpPr>
+          <p:cNvPr id="6" name="TextBox 5"/>
+          <p:cNvSpPr txBox="1"/>
+          <p:nvPr/>
+        </p:nvSpPr>
+        <p:spPr>
+          <a:xfrm>
+            <a:off x="6263640" y="1783080"/>
+            <a:ext cx="4983480" cy="320040"/>
+          </a:xfrm>
+          <a:prstGeom prst="rect">
+            <a:avLst/>
+          </a:prstGeom>
+          <a:noFill/>
+        </p:spPr>
+        <p:txBody>
+          <a:bodyPr wrap="none">
+            <a:spAutoFit/>
+          </a:bodyPr>
+          <a:lstStyle/>
+          <a:p>
+            <a:pPr>
+              <a:defRPr sz="1350" b="1">
+                <a:solidFill>
+                  <a:srgbClr val="0F172A"/>
+                </a:solidFill>
+                <a:latin typeface="Segoe UI"/>
+              </a:defRPr>
+            </a:pPr>
+            <a:r>
+              <a:t>✨ A Cleaner City with Intelligent Waste Bins</a:t>
+            </a:r>
+          </a:p>
+        </p:txBody>
+      </p:sp>
+      <p:pic>
+        <p:nvPicPr>
+          <p:cNvPr id="7" name="Picture 6" descr="clean_city_illustration_png_1792698653752.jpg"/>
+          <p:cNvPicPr>
+            <a:picLocks noChangeAspect="1"/>
+          </p:cNvPicPr>
+          <p:nvPr/>
+        </p:nvPicPr>
+        <p:blipFill>
+          <a:blip r:embed="rId2"/>
+          <a:stretch>
+            <a:fillRect/>
+          </a:stretch>
+        </p:blipFill>
+        <p:spPr>
+          <a:xfrm>
+            <a:off x="6263640" y="2176272"/>
+            <a:ext cx="4983480" cy="2781477"/>
+          </a:xfrm>
+          <a:prstGeom prst="rect">
+            <a:avLst/>
+          </a:prstGeom>
+        </p:spPr>
+      </p:pic>
+      <p:sp>
+        <p:nvSpPr>
+          <p:cNvPr id="8" name="Rounded Rectangle 7"/>
+          <p:cNvSpPr/>
+          <p:nvPr/>
+        </p:nvSpPr>
+        <p:spPr>
+          <a:xfrm>
+            <a:off x="6263640" y="5138928"/>
+            <a:ext cx="4983480" cy="841248"/>
+          </a:xfrm>
+          <a:prstGeom prst="roundRect">
+            <a:avLst/>
+          </a:prstGeom>
+          <a:solidFill>
+            <a:srgbClr val="FFFFFF"/>
+          </a:solidFill>
+          <a:ln w="15240">
+            <a:solidFill>
+              <a:srgbClr val="10B981"/>
+            </a:solidFill>
+          </a:ln>
+        </p:spPr>
+        <p:style>
+          <a:lnRef idx="1">
+            <a:schemeClr val="accent1"/>
+          </a:lnRef>
+          <a:fillRef idx="3">
+            <a:schemeClr val="accent1"/>
+          </a:fillRef>
+          <a:effectRef idx="2">
+            <a:schemeClr val="accent1"/>
+          </a:effectRef>
+          <a:fontRef idx="minor">
+            <a:schemeClr val="lt1"/>
+          </a:fontRef>
+        </p:style>
+        <p:txBody>
+          <a:bodyPr rtlCol="0" anchor="ctr" wrap="square"/>
+          <a:lstStyle/>
+          <a:p>
+            <a:pPr algn="ctr">
+              <a:defRPr sz="1100" b="1">
+                <a:solidFill>
+                  <a:srgbClr val="10B981"/>
+                </a:solidFill>
+                <a:latin typeface="Segoe UI"/>
+              </a:defRPr>
+            </a:pPr>
+            <a:r>
+              <a:t>Spotless Pavements  •  Happy Citizens  •  Smart Fleet Optimization</a:t>
+            </a:r>
+          </a:p>
+          <a:p>
+            <a:pPr algn="ctr">
+              <a:spcBef>
+                <a:spcPts val="300"/>
+              </a:spcBef>
+              <a:defRPr sz="950">
+                <a:solidFill>
+                  <a:srgbClr val="64748B"/>
+                </a:solidFill>
+                <a:latin typeface="Segoe UI"/>
+              </a:defRPr>
+            </a:pPr>
+            <a:r>
+              <a:t>Daneben! Smart Waste Bin Detection System</a:t>
+            </a:r>
+          </a:p>
+        </p:txBody>
+      </p:sp>
+      <p:sp>
+        <p:nvSpPr>
+          <p:cNvPr id="9" name="TextBox 8"/>
+          <p:cNvSpPr txBox="1"/>
+          <p:nvPr/>
+        </p:nvSpPr>
+        <p:spPr>
+          <a:xfrm>
+            <a:off x="731520" y="6537960"/>
+            <a:ext cx="10698480" cy="274320"/>
+          </a:xfrm>
+          <a:prstGeom prst="rect">
+            <a:avLst/>
+          </a:prstGeom>
+          <a:noFill/>
+        </p:spPr>
+        <p:txBody>
+          <a:bodyPr wrap="none">
+            <a:spAutoFit/>
+          </a:bodyPr>
+          <a:lstStyle/>
+          <a:p>
+            <a:pPr>
+              <a:defRPr sz="950">
+                <a:solidFill>
+                  <a:srgbClr val="64748B"/>
+                </a:solidFill>
+                <a:latin typeface="Segoe UI"/>
+              </a:defRPr>
+            </a:pPr>
+            <a:r>
+              <a:t>DANEBEN!  |  Production Presentation &amp; Sales Pitch (Standard Edition)  |  Slide 9 of 9</a:t>
             </a:r>
           </a:p>
         </p:txBody>

</xml_diff>